<commit_message>
BRD-13 Migration Workbook: load templates in the guided design (Load templates index in load order, one sheet per layout with review rows and guide band above the file header, example row, drop-downs, Reference lists), questions per template and column in the Comments log; handbook, Start Here and guide deck texts and the workbook picture of the deck updated
</commit_message>
<xml_diff>
--- a/docs/deliverables/out/Drop-0_Setup_and_Data_Migration/BRD-13_Data_Migration/01_BIBS_GuideDeck_BRD-13_Data_Migration_v2.0.pptx
+++ b/docs/deliverables/out/Drop-0_Setup_and_Data_Migration/BRD-13_Data_Migration/01_BIBS_GuideDeck_BRD-13_Data_Migration_v2.0.pptx
@@ -24089,7 +24089,7 @@
       </p:sp>
       <p:pic>
         <p:nvPicPr>
-          <p:cNvPr id="9" name="Picture 8" descr="signoff-workbook-c01-client-master.png"/>
+          <p:cNvPr id="9" name="Picture 8" descr="signoff-workbook-object-catalogue.png"/>
           <p:cNvPicPr>
             <a:picLocks noChangeAspect="1"/>
           </p:cNvPicPr>
@@ -24104,7 +24104,7 @@
         <p:spPr>
           <a:xfrm>
             <a:off x="548640" y="1325880"/>
-            <a:ext cx="7498079" cy="1708298"/>
+            <a:ext cx="7498079" cy="2607741"/>
           </a:xfrm>
           <a:prstGeom prst="rect">
             <a:avLst/>
@@ -24146,7 +24146,7 @@
                 </a:solidFill>
                 <a:latin typeface="Arial"/>
               </a:rPr>
-              <a:t>Load template sheet C01 of the Migration Workbook</a:t>
+              <a:t>Object catalogue sheet of the Migration Workbook</a:t>
             </a:r>
           </a:p>
         </p:txBody>
@@ -24282,7 +24282,32 @@
                 </a:solidFill>
                 <a:latin typeface="Arial"/>
               </a:rPr>
-              <a:t>Review the rows of your objects: Object catalogue, Data owners, the load template sheets, Code maps, Validation rules, Cut-over tasks, Reconciliation sign-off</a:t>
+              <a:t>Review the rows of your objects: Object catalogue, Data owners, Code maps, Validation rules, Cut-over tasks, Reconciliation sign-off</a:t>
+            </a:r>
+          </a:p>
+          <a:p>
+            <a:pPr>
+              <a:spcAft>
+                <a:spcPts val="600"/>
+              </a:spcAft>
+            </a:pPr>
+            <a:r>
+              <a:rPr sz="1300">
+                <a:solidFill>
+                  <a:srgbClr val="004EA8"/>
+                </a:solidFill>
+                <a:latin typeface="Arial"/>
+              </a:rPr>
+              <a:t>•  </a:t>
+            </a:r>
+            <a:r>
+              <a:rPr sz="1300">
+                <a:solidFill>
+                  <a:srgbClr val="4B4B4B"/>
+                </a:solidFill>
+                <a:latin typeface="Arial"/>
+              </a:rPr>
+              <a:t>Load templates: in load order; on each template sheet the BU review rows sit above the columns</a:t>
             </a:r>
           </a:p>
           <a:p>

</xml_diff>

<commit_message>
BRD-13 Data Migration screenshots retaken in the BDO style-guide presentation on a fresh seed stack: 71 images; Handbook, guide deck, migration workbook and UX documents 07 to 09 rebuilt at v2.0 with issue 2.2 change CHG-DM-2.2-01; Remove of a legacy batch line described in its row action menu; drop indexes
</commit_message>
<xml_diff>
--- a/docs/deliverables/out/Drop-0_Setup_and_Data_Migration/BRD-13_Data_Migration/01_BIBS_GuideDeck_BRD-13_Data_Migration_v2.0.pptx
+++ b/docs/deliverables/out/Drop-0_Setup_and_Data_Migration/BRD-13_Data_Migration/01_BIBS_GuideDeck_BRD-13_Data_Migration_v2.0.pptx
@@ -11953,8 +11953,8 @@
         </p:blipFill>
         <p:spPr>
           <a:xfrm>
-            <a:off x="2299123" y="1325880"/>
-            <a:ext cx="1909080" cy="1874520"/>
+            <a:off x="2355867" y="1325880"/>
+            <a:ext cx="1795592" cy="1874520"/>
           </a:xfrm>
           <a:prstGeom prst="rect">
             <a:avLst/>
@@ -12017,8 +12017,8 @@
         </p:blipFill>
         <p:spPr>
           <a:xfrm>
-            <a:off x="7955009" y="1325880"/>
-            <a:ext cx="1966042" cy="1874520"/>
+            <a:off x="7942406" y="1325880"/>
+            <a:ext cx="1991248" cy="1874520"/>
           </a:xfrm>
           <a:prstGeom prst="rect">
             <a:avLst/>
@@ -12081,8 +12081,8 @@
         </p:blipFill>
         <p:spPr>
           <a:xfrm>
-            <a:off x="2514560" y="3566160"/>
-            <a:ext cx="1478207" cy="1874519"/>
+            <a:off x="2693240" y="3566160"/>
+            <a:ext cx="1120847" cy="1874520"/>
           </a:xfrm>
           <a:prstGeom prst="rect">
             <a:avLst/>
@@ -12145,8 +12145,8 @@
         </p:blipFill>
         <p:spPr>
           <a:xfrm>
-            <a:off x="7976999" y="3566160"/>
-            <a:ext cx="1922062" cy="1874520"/>
+            <a:off x="7957459" y="3566160"/>
+            <a:ext cx="1961142" cy="1874520"/>
           </a:xfrm>
           <a:prstGeom prst="rect">
             <a:avLst/>
@@ -14472,7 +14472,7 @@
                 </a:solidFill>
                 <a:latin typeface="Arial"/>
               </a:rPr>
-              <a:t>Content: 20 screens, 190 fields, 68 business rules, 216 messages</a:t>
+              <a:t>Content: 20 screens, 190 fields, 68 business rules, 217 messages</a:t>
             </a:r>
           </a:p>
           <a:p>
@@ -18099,7 +18099,7 @@
                 </a:solidFill>
                 <a:latin typeface="Arial"/>
               </a:rPr>
-              <a:t>Full list: Handbook Part B, chapter 19 per screen, 68 rules on the Business rules sheet and 216 messages in Handbook Part B, chapter 21 and on the Messages sheet</a:t>
+              <a:t>Full list: Handbook Part B, chapter 19 per screen, 68 rules on the Business rules sheet and 217 messages in Handbook Part B, chapter 21 and on the Messages sheet</a:t>
             </a:r>
           </a:p>
         </p:txBody>

</xml_diff>